<commit_message>
Second review pass: fix SQL examples, wording and numbering
- L4: INSERT/ALTER/UPDATE examples use a persons table (students has
  required id/first_name), Oracle date literal note, SQL Server ALTER COLUMN,
  COUNT(*) vs NULLs wording, subquery/UNION examples use real COMPANY
  locations (Houston, Stafford)
- L1: NoSQL schema wording, three-tier note, clearer practice Q6
- L2: crow's foot slide explains why PK/FK columns appear
- L3: recap/quiz eyebrow numbers, 1:N title spacing, closing notes
- L5: practice wording

Co-Authored-By: Claude Opus 5.5 <noreply@anthropic.com>
Claude-Session: https://claude.ai/code/session_01R46jZmLWPYVdN2LncsYeT8
</commit_message>
<xml_diff>
--- a/pptx/ITI_Database_Course_Lesson_1_Introduction.pptx
+++ b/pptx/ITI_Database_Course_Lesson_1_Introduction.pptx
@@ -12576,7 +12576,25 @@
                 </a:solidFill>
                 <a:latin typeface="Calibri"/>
               </a:rPr>
-              <a:t>No fixed tables, rows or foreign keys. Each store uses a </a:t>
+              <a:t>Usually </a:t>
+            </a:r>
+            <a:r>
+              <a:rPr sz="3091" b="1" i="0" u="none">
+                <a:solidFill>
+                  <a:srgbClr val="334155"/>
+                </a:solidFill>
+                <a:latin typeface="Calibri"/>
+              </a:rPr>
+              <a:t>no fixed schema and no foreign keys</a:t>
+            </a:r>
+            <a:r>
+              <a:rPr sz="3091" b="0" i="0" u="none">
+                <a:solidFill>
+                  <a:srgbClr val="334155"/>
+                </a:solidFill>
+                <a:latin typeface="Calibri"/>
+              </a:rPr>
+              <a:t>. Each store uses a </a:t>
             </a:r>
             <a:r>
               <a:rPr sz="3091" b="1" i="0" u="none">
@@ -18105,7 +18123,7 @@
         <p:spPr>
           <a:xfrm>
             <a:off x="9525000" y="7810500"/>
-            <a:ext cx="7543800" cy="626554"/>
+            <a:ext cx="7543800" cy="922743"/>
           </a:xfrm>
           <a:prstGeom prst="rect">
             <a:avLst/>
@@ -18128,7 +18146,7 @@
                 </a:solidFill>
                 <a:latin typeface="Calibri"/>
               </a:rPr>
-              <a:t>Only the server runs the application; users need just a browser. The database is never exposed to the internet.</a:t>
+              <a:t>Only the server runs the application; users need just a browser. The database server stays behind the app server, off the public internet.</a:t>
             </a:r>
           </a:p>
         </p:txBody>
@@ -21385,7 +21403,7 @@
         <p:spPr>
           <a:xfrm>
             <a:off x="12432030" y="6829520"/>
-            <a:ext cx="4594859" cy="1584613"/>
+            <a:ext cx="4594859" cy="1969659"/>
           </a:xfrm>
           <a:prstGeom prst="rect">
             <a:avLst/>
@@ -21408,7 +21426,7 @@
                 </a:solidFill>
                 <a:latin typeface="Calibri"/>
               </a:rPr>
-              <a:t>Open db-fiddle.com (PostgreSQL), create a table and insert 3 rows. Which schema level did each statement touch?</a:t>
+              <a:t>Open db-fiddle.com (PostgreSQL) and run CREATE TABLE, then CREATE INDEX on one column. Which level of the three-schema architecture does each statement change?</a:t>
             </a:r>
           </a:p>
         </p:txBody>

</xml_diff>

<commit_message>
Fix Lesson 3 modelling issues and align agendas with content
- L3 car case: replace the ternary with MODEL uses PART (M:N) and MODEL
  produced_at FACTORY (N:1); tables now model.factory_city (FK) and
  model_part junction, removing the 2NF violation
- L3 weak entity: partial key (weekday, start_time), ERD and table updated
- L3 bus case: route columns start_point/end_point (END is reserved)
- L3 agenda lists summary, pitfalls, 3 case studies, recap; bank slides
  labelled like the car and bus cases
- L1/L2/L4/L5 section descriptions now match the slides in each section
- L2 car hints match the Lesson 3 solution

Co-Authored-By: Claude Opus 5.5 <noreply@anthropic.com>
Claude-Session: https://claude.ai/code/session_01R46jZmLWPYVdN2LncsYeT8
</commit_message>
<xml_diff>
--- a/pptx/ITI_Database_Course_Lesson_1_Introduction.pptx
+++ b/pptx/ITI_Database_Course_Lesson_1_Introduction.pptx
@@ -11880,7 +11880,7 @@
                 </a:solidFill>
                 <a:latin typeface="Calibri"/>
               </a:rPr>
-              <a:t>Why organizations moved from separate program files to a shared, managed database.</a:t>
+              <a:t>Why organizations moved from program files to a shared database, what a DBMS does, and who works with it.</a:t>
             </a:r>
           </a:p>
         </p:txBody>
@@ -23533,7 +23533,7 @@
                 </a:solidFill>
                 <a:latin typeface="Calibri"/>
               </a:rPr>
-              <a:t>Why organizations moved from separate program files to a shared, managed database.</a:t>
+              <a:t>Why organizations moved from program files to a shared database, what a DBMS does, and who works with it.</a:t>
             </a:r>
           </a:p>
         </p:txBody>

</xml_diff>